<commit_message>
Update entity PNL report template and export logic
Replit-Commit-Author: Agent
</commit_message>
<xml_diff>
--- a/attached_assets/entity_pnl_bosch_template.pptx
+++ b/attached_assets/entity_pnl_bosch_template.pptx
@@ -574,12 +574,6 @@
 </p:sldLayout>
 </file>
 
-<file path=ppt/slideLayouts/slideLayout2.xml><?xml version="1.0" encoding="UTF-8" standalone="yes"?>
-		<p:sldLayout xmlns:a="http://schemas.openxmlformats.org/drawingml/2006/main" xmlns:r="http://schemas.openxmlformats.org/officeDocument/2006/relationships" xmlns:p="http://schemas.openxmlformats.org/presentationml/2006/main" preserve="1">
-		<p:cSld name="P&L_MASTER"><p:bg><p:bgPr><a:solidFill><a:srgbClr val="FFFFFF"/></a:solidFill></p:bgPr></p:bg><p:spTree><p:nvGrpSpPr><p:cNvPr id="1" name=""/><p:cNvGrpSpPr/><p:nvPr/></p:nvGrpSpPr><p:grpSpPr><a:xfrm><a:off x="0" y="0"/><a:ext cx="0" cy="0"/><a:chOff x="0" y="0"/><a:chExt cx="0" cy="0"/></a:xfrm></p:grpSpPr><p:sp><p:nvSpPr><p:cNvPr id="2" name="Shape 0"></p:cNvPr><p:cNvSpPr/><p:nvPr></p:nvPr></p:nvSpPr><p:spPr><a:xfrm><a:off x="0" y="6565392"/><a:ext cx="12188952" cy="292608"/></a:xfrm><a:prstGeom prst="rect"><a:avLst></a:avLst></a:prstGeom><a:solidFill><a:srgbClr val="00A7B5"/></a:solidFill><a:ln w="12700"><a:solidFill><a:srgbClr val="00A7B5"/></a:solidFill><a:prstDash val="solid"/></a:ln></p:spPr></p:sp><p:sp><p:nvSpPr><p:cNvPr id="3" name="Shape 1"></p:cNvPr><p:cNvSpPr/><p:nvPr></p:nvPr></p:nvSpPr><p:spPr><a:xfrm><a:off x="0" y="6565392"/><a:ext cx="7909560" cy="292608"/></a:xfrm><a:prstGeom prst="rect"><a:avLst></a:avLst></a:prstGeom><a:solidFill><a:srgbClr val="008A99"/></a:solidFill><a:ln w="12700"><a:solidFill><a:srgbClr val="008A99"/></a:solidFill><a:prstDash val="solid"/></a:ln></p:spPr></p:sp><p:sp><p:nvSpPr><p:cNvPr id="4" name="Shape 2"></p:cNvPr><p:cNvSpPr/><p:nvPr></p:nvPr></p:nvSpPr><p:spPr><a:xfrm><a:off x="7909560" y="6565392"/><a:ext cx="2423160" cy="292608"/></a:xfrm><a:prstGeom prst="rect"><a:avLst></a:avLst></a:prstGeom><a:solidFill><a:srgbClr val="E20015"/></a:solidFill><a:ln w="12700"><a:solidFill><a:srgbClr val="E20015"/></a:solidFill><a:prstDash val="solid"/></a:ln></p:spPr></p:sp><p:sp><p:nvSpPr><p:cNvPr id="5" name="Shape 3"></p:cNvPr><p:cNvSpPr/><p:nvPr></p:nvPr></p:nvSpPr><p:spPr><a:xfrm><a:off x="10332720" y="6565392"/><a:ext cx="1856232" cy="292608"/></a:xfrm><a:prstGeom prst="rect"><a:avLst></a:avLst></a:prstGeom><a:solidFill><a:srgbClr val="00A7B5"/></a:solidFill><a:ln w="12700"><a:solidFill><a:srgbClr val="00A7B5"/></a:solidFill><a:prstDash val="solid"/></a:ln></p:spPr></p:sp><p:sp><p:nvSpPr><p:cNvPr id="6" name="Text 4"></p:cNvPr><p:cNvSpPr/><p:nvPr></p:nvPr></p:nvSpPr><p:spPr><a:xfrm><a:off x="384048" y="6601968"/><a:ext cx="4023360" cy="109728"/></a:xfrm><a:prstGeom prst="rect"><a:avLst></a:avLst></a:prstGeom><a:noFill/><a:ln></a:ln></p:spPr><p:txBody><a:bodyPr wrap="square" lIns="0" tIns="0" rIns="0" bIns="0" rtlCol="0" anchor="ctr"></a:bodyPr><a:lstStyle/><a:p><a:pPr indent="0" marL="0"><a:buNone/></a:pPr><a:r><a:rPr lang="en-US" sz="550" dirty="0"><a:solidFill><a:srgbClr val="FFFFFF"/></a:solidFill><a:latin typeface="Arial" pitchFamily="34" charset="0"/><a:ea typeface="Arial" pitchFamily="34" charset="-122"/><a:cs typeface="Arial" pitchFamily="34" charset="-120"/></a:rPr><a:t>Internal | Governed Enterprise Data</a:t></a:r><a:endParaRPr lang="en-US" sz="550" dirty="0"/></a:p></p:txBody></p:sp><p:sp><p:nvSpPr><p:cNvPr id="7" name="Text 5"></p:cNvPr><p:cNvSpPr/><p:nvPr></p:nvPr></p:nvSpPr><p:spPr><a:xfrm><a:off x="10817352" y="6574536"/><a:ext cx="822960" cy="164592"/></a:xfrm><a:prstGeom prst="rect"><a:avLst></a:avLst></a:prstGeom><a:noFill/><a:ln></a:ln></p:spPr><p:txBody><a:bodyPr wrap="square" lIns="0" tIns="0" rIns="0" bIns="0" rtlCol="0" anchor="ctr"></a:bodyPr><a:lstStyle/><a:p><a:pPr algn="ctr" indent="0" marL="0"><a:buNone/></a:pPr><a:r><a:rPr lang="en-US" sz="800" b="1" dirty="0"><a:solidFill><a:srgbClr val="FFFFFF"/></a:solidFill><a:latin typeface="Arial" pitchFamily="34" charset="0"/><a:ea typeface="Arial" pitchFamily="34" charset="-122"/><a:cs typeface="Arial" pitchFamily="34" charset="-120"/></a:rPr><a:t>BOSCH</a:t></a:r><a:endParaRPr lang="en-US" sz="800" dirty="0"/></a:p></p:txBody></p:sp><p:sp> <p:nvSpPr>  <p:cNvPr id="25" name="Slide Number Placeholder 0"/><p:cNvSpPr><a:spLocks noGrp="1"/></p:cNvSpPr>  <p:nvPr><p:ph type="sldNum" sz="quarter" idx="4294967295"/></p:nvPr> </p:nvSpPr> <p:spPr><a:xfrm><a:off x="329184" y="6345936"/><a:ext cx="800000" cy="300000"/></a:xfrm> <a:prstGeom prst="rect"><a:avLst/></a:prstGeom> <a:extLst><a:ext uri="{C572A759-6A51-4108-AA02-DFA0A04FC94B}"><ma14:wrappingTextBoxFlag val="0" xmlns:ma14="http://schemas.microsoft.com/office/mac/drawingml/2011/main"/></a:ext></a:extLst></p:spPr><p:txBody><a:bodyPr/>  <a:lstStyle><a:lvl1pPr><a:defRPr sz="700"><a:solidFill><a:srgbClr val="65747A"/></a:solidFill><a:latin typeface="Arial"/><a:ea typeface="Arial"/><a:cs typeface="Arial"/></a:defRPr></a:lvl1pPr></a:lstStyle><a:p><a:pPr algn="l"/><a:fld id="{F7021451-1387-4CA6-816F-3879F97B5CBC}" type="slidenum"><a:rPr b="0" lang="en-US"/><a:t>1002</a:t></a:fld><a:endParaRPr lang="en-US"/></a:p></p:txBody></p:sp></p:spTree></p:cSld>
-		<p:clrMapOvr><a:masterClrMapping/></p:clrMapOvr></p:sldLayout>
-</file>
-
 <file path=ppt/slideMasters/slideMaster1.xml><?xml version="1.0" encoding="utf-8"?>
 <p:sldMaster xmlns:a="http://schemas.openxmlformats.org/drawingml/2006/main" xmlns:r="http://schemas.openxmlformats.org/officeDocument/2006/relationships" xmlns:p="http://schemas.openxmlformats.org/presentationml/2006/main">
   <p:cSld>
@@ -597,60 +591,11 @@
           <a:chExt cx="0" cy="0"/>
         </a:xfrm>
       </p:grpSpPr>
-      <p:sp>
-        <p:nvSpPr>
-          <p:cNvPr id="25" name="Slide Number Placeholder 0"/>
-          <p:cNvSpPr>
-            <a:spLocks noGrp="1"/>
-          </p:cNvSpPr>
-          <p:nvPr>
-            <p:ph type="sldNum" sz="quarter" idx="4294967295"/>
-          </p:nvPr>
-        </p:nvSpPr>
-        <p:spPr>
-          <a:xfrm>
-            <a:off x="329184" y="6345936"/>
-            <a:ext cx="800000" cy="300000"/>
-          </a:xfrm>
-          <a:prstGeom prst="rect">
-            <a:avLst/>
-          </a:prstGeom>
-          <a:extLst>
-            <a:ext uri="{C572A759-6A51-4108-AA02-DFA0A04FC94B}">
-              <ma14:wrappingTextBoxFlag xmlns:ma14="http://schemas.microsoft.com/office/mac/drawingml/2011/main" val="0"/>
-            </a:ext>
-          </a:extLst>
-        </p:spPr>
-        <p:txBody>
-          <a:bodyPr/>
-          <a:lstStyle>
-            <a:lvl1pPr>
-              <a:defRPr sz="700">
-                <a:solidFill>
-                  <a:srgbClr val="65747A"/>
-                </a:solidFill>
-                <a:latin typeface="Arial"/>
-                <a:ea typeface="Arial"/>
-                <a:cs typeface="Arial"/>
-              </a:defRPr>
-            </a:lvl1pPr>
-          </a:lstStyle>
-          <a:p>
-            <a:pPr algn="l"/>
-            <a:fld id="{F7021451-1387-4CA6-816F-3879F97B5CBC}" type="slidenum">
-              <a:rPr b="0" lang="en-US"/>
-              <a:t>null</a:t>
-            </a:fld>
-            <a:endParaRPr lang="en-US"/>
-          </a:p>
-        </p:txBody>
-      </p:sp>
     </p:spTree>
   </p:cSld>
   <p:clrMap bg1="lt1" tx1="dk1" bg2="lt2" tx2="dk2" accent1="accent1" accent2="accent2" accent3="accent3" accent4="accent4" accent5="accent5" accent6="accent6" hlink="hlink" folHlink="folHlink"/>
   <p:sldLayoutIdLst>
     <p:sldLayoutId id="2147483649" r:id="rId1"/>
-    <p:sldLayoutId id="2147483650" r:id="rId2"/>
   </p:sldLayoutIdLst>
   <p:hf sldNum="0" hdr="0" ftr="0" dt="0"/>
   <p:txStyles>
@@ -10103,49 +10048,160 @@
       </p:sp>
       <p:sp>
         <p:nvSpPr>
-          <p:cNvPr id="25" name="Slide Number Placeholder 0"/>
-          <p:cNvSpPr>
-            <a:spLocks noGrp="1"/>
-          </p:cNvSpPr>
-          <p:nvPr>
-            <p:ph type="sldNum" sz="quarter" idx="4294967295"/>
-          </p:nvPr>
+          <p:cNvPr id="25" name="Shape 22"/>
+          <p:cNvSpPr/>
+          <p:nvPr/>
         </p:nvSpPr>
         <p:spPr>
           <a:xfrm>
-            <a:off x="329184" y="6345936"/>
-            <a:ext cx="800000" cy="300000"/>
+            <a:off x="0" y="6565392"/>
+            <a:ext cx="7909560" cy="292608"/>
           </a:xfrm>
           <a:prstGeom prst="rect">
             <a:avLst/>
           </a:prstGeom>
-          <a:extLst>
-            <a:ext uri="{C572A759-6A51-4108-AA02-DFA0A04FC94B}">
-              <ma14:wrappingTextBoxFlag xmlns:ma14="http://schemas.microsoft.com/office/mac/drawingml/2011/main" val="0"/>
-            </a:ext>
-          </a:extLst>
+          <a:solidFill>
+            <a:srgbClr val="008A99"/>
+          </a:solidFill>
+          <a:ln w="12700">
+            <a:solidFill>
+              <a:srgbClr val="008A99">
+                <a:alpha val="0"/>
+              </a:srgbClr>
+            </a:solidFill>
+            <a:prstDash val="solid"/>
+          </a:ln>
+        </p:spPr>
+      </p:sp>
+      <p:sp>
+        <p:nvSpPr>
+          <p:cNvPr id="26" name="Shape 23"/>
+          <p:cNvSpPr/>
+          <p:nvPr/>
+        </p:nvSpPr>
+        <p:spPr>
+          <a:xfrm>
+            <a:off x="7909560" y="6565392"/>
+            <a:ext cx="2423160" cy="292608"/>
+          </a:xfrm>
+          <a:prstGeom prst="rect">
+            <a:avLst/>
+          </a:prstGeom>
+          <a:solidFill>
+            <a:srgbClr val="E20015"/>
+          </a:solidFill>
+          <a:ln w="12700">
+            <a:solidFill>
+              <a:srgbClr val="E20015">
+                <a:alpha val="0"/>
+              </a:srgbClr>
+            </a:solidFill>
+            <a:prstDash val="solid"/>
+          </a:ln>
+        </p:spPr>
+      </p:sp>
+      <p:sp>
+        <p:nvSpPr>
+          <p:cNvPr id="27" name="Shape 24"/>
+          <p:cNvSpPr/>
+          <p:nvPr/>
+        </p:nvSpPr>
+        <p:spPr>
+          <a:xfrm>
+            <a:off x="10332720" y="6565392"/>
+            <a:ext cx="1856232" cy="292608"/>
+          </a:xfrm>
+          <a:prstGeom prst="rect">
+            <a:avLst/>
+          </a:prstGeom>
+          <a:solidFill>
+            <a:srgbClr val="00A7B5"/>
+          </a:solidFill>
+          <a:ln w="12700">
+            <a:solidFill>
+              <a:srgbClr val="00A7B5">
+                <a:alpha val="0"/>
+              </a:srgbClr>
+            </a:solidFill>
+            <a:prstDash val="solid"/>
+          </a:ln>
+        </p:spPr>
+      </p:sp>
+      <p:sp>
+        <p:nvSpPr>
+          <p:cNvPr id="28" name="Text 25"/>
+          <p:cNvSpPr/>
+          <p:nvPr/>
+        </p:nvSpPr>
+        <p:spPr>
+          <a:xfrm>
+            <a:off x="384048" y="6601968"/>
+            <a:ext cx="4023360" cy="109728"/>
+          </a:xfrm>
+          <a:prstGeom prst="rect">
+            <a:avLst/>
+          </a:prstGeom>
+          <a:noFill/>
+          <a:ln/>
         </p:spPr>
         <p:txBody>
-          <a:bodyPr/>
-          <a:lstStyle>
-            <a:lvl1pPr>
-              <a:defRPr sz="700">
+          <a:bodyPr wrap="square" lIns="0" tIns="0" rIns="0" bIns="0" rtlCol="0" anchor="ctr"/>
+          <a:lstStyle/>
+          <a:p>
+            <a:pPr indent="0" marL="0">
+              <a:buNone/>
+            </a:pPr>
+            <a:r>
+              <a:rPr lang="en-US" sz="550" dirty="0">
                 <a:solidFill>
-                  <a:srgbClr val="65747A"/>
+                  <a:srgbClr val="FFFFFF"/>
                 </a:solidFill>
-                <a:latin typeface="Arial"/>
-                <a:ea typeface="Arial"/>
-                <a:cs typeface="Arial"/>
-              </a:defRPr>
-            </a:lvl1pPr>
-          </a:lstStyle>
+                <a:latin typeface="Arial" pitchFamily="34" charset="0"/>
+                <a:ea typeface="Arial" pitchFamily="34" charset="-122"/>
+                <a:cs typeface="Arial" pitchFamily="34" charset="-120"/>
+              </a:rPr>
+              <a:t>Internal | Governed Enterprise Data</a:t>
+            </a:r>
+            <a:endParaRPr lang="en-US" sz="550" dirty="0"/>
+          </a:p>
+        </p:txBody>
+      </p:sp>
+      <p:sp>
+        <p:nvSpPr>
+          <p:cNvPr id="29" name="Text 26"/>
+          <p:cNvSpPr/>
+          <p:nvPr/>
+        </p:nvSpPr>
+        <p:spPr>
+          <a:xfrm>
+            <a:off x="10817352" y="6574536"/>
+            <a:ext cx="822960" cy="164592"/>
+          </a:xfrm>
+          <a:prstGeom prst="rect">
+            <a:avLst/>
+          </a:prstGeom>
+          <a:noFill/>
+          <a:ln/>
+        </p:spPr>
+        <p:txBody>
+          <a:bodyPr wrap="square" lIns="0" tIns="0" rIns="0" bIns="0" rtlCol="0" anchor="ctr"/>
+          <a:lstStyle/>
           <a:p>
-            <a:pPr algn="l"/>
-            <a:fld id="{F7021451-1387-4CA6-816F-3879F97B5CBC}" type="slidenum">
-              <a:rPr b="0" lang="en-US"/>
-              <a:t>1</a:t>
-            </a:fld>
-            <a:endParaRPr lang="en-US"/>
+            <a:pPr algn="ctr" indent="0" marL="0">
+              <a:buNone/>
+            </a:pPr>
+            <a:r>
+              <a:rPr lang="en-US" sz="800" b="1" dirty="0">
+                <a:solidFill>
+                  <a:srgbClr val="FFFFFF"/>
+                </a:solidFill>
+                <a:latin typeface="Arial" pitchFamily="34" charset="0"/>
+                <a:ea typeface="Arial" pitchFamily="34" charset="-122"/>
+                <a:cs typeface="Arial" pitchFamily="34" charset="-120"/>
+              </a:rPr>
+              <a:t>BOSCH</a:t>
+            </a:r>
+            <a:endParaRPr lang="en-US" sz="800" dirty="0"/>
           </a:p>
         </p:txBody>
       </p:sp>

</xml_diff>